<commit_message>
Added SQL ACID slide
</commit_message>
<xml_diff>
--- a/presentation/IKT NoSql Sql Elastic Search.pptx
+++ b/presentation/IKT NoSql Sql Elastic Search.pptx
@@ -7,10 +7,11 @@
   <p:sldIdLst>
     <p:sldId id="256" r:id="rId2"/>
     <p:sldId id="257" r:id="rId3"/>
-    <p:sldId id="258" r:id="rId4"/>
-    <p:sldId id="259" r:id="rId5"/>
-    <p:sldId id="260" r:id="rId6"/>
-    <p:sldId id="261" r:id="rId7"/>
+    <p:sldId id="262" r:id="rId4"/>
+    <p:sldId id="258" r:id="rId5"/>
+    <p:sldId id="259" r:id="rId6"/>
+    <p:sldId id="260" r:id="rId7"/>
+    <p:sldId id="261" r:id="rId8"/>
   </p:sldIdLst>
   <p:sldSz cx="12192000" cy="6858000"/>
   <p:notesSz cx="6858000" cy="9144000"/>
@@ -120,8 +121,7 @@
 <file path=ppt/revisionInfo.xml><?xml version="1.0" encoding="utf-8"?>
 <p1510:revInfo xmlns:a="http://schemas.openxmlformats.org/drawingml/2006/main" xmlns:r="http://schemas.openxmlformats.org/officeDocument/2006/relationships" xmlns:p1510="http://schemas.microsoft.com/office/powerpoint/2015/10/main">
   <p1510:revLst>
-    <p1510:client id="{1629F522-D3CB-18F1-93F6-8C0AE87C9E43}" v="16" dt="2026-03-31T12:50:47.559"/>
-    <p1510:client id="{C0A5C56B-A0E4-6BD3-6131-9CB4D1AD8AFC}" v="341" dt="2026-03-31T12:47:46.694"/>
+    <p1510:client id="{93730699-C387-F3AA-CD03-6BA47E2D74A8}" v="179" dt="2026-04-13T15:55:23.925"/>
   </p1510:revLst>
 </p1510:revInfo>
 </file>
@@ -282,7 +282,7 @@
           <a:p>
             <a:fld id="{02AC24A9-CCB6-4F8D-B8DB-C2F3692CFA5A}" type="datetimeFigureOut">
               <a:rPr lang="en-US" smtClean="0"/>
-              <a:t>3/31/2026</a:t>
+              <a:t>4/13/2026</a:t>
             </a:fld>
             <a:endParaRPr lang="en-US" dirty="0"/>
           </a:p>
@@ -652,7 +652,7 @@
           <a:p>
             <a:fld id="{02AC24A9-CCB6-4F8D-B8DB-C2F3692CFA5A}" type="datetimeFigureOut">
               <a:rPr lang="en-US" smtClean="0"/>
-              <a:t>3/31/2026</a:t>
+              <a:t>4/13/2026</a:t>
             </a:fld>
             <a:endParaRPr lang="en-US"/>
           </a:p>
@@ -861,7 +861,7 @@
           <a:p>
             <a:fld id="{02AC24A9-CCB6-4F8D-B8DB-C2F3692CFA5A}" type="datetimeFigureOut">
               <a:rPr lang="en-US" smtClean="0"/>
-              <a:t>3/31/2026</a:t>
+              <a:t>4/13/2026</a:t>
             </a:fld>
             <a:endParaRPr lang="en-US"/>
           </a:p>
@@ -1331,7 +1331,7 @@
           <a:p>
             <a:fld id="{02AC24A9-CCB6-4F8D-B8DB-C2F3692CFA5A}" type="datetimeFigureOut">
               <a:rPr lang="en-US" smtClean="0"/>
-              <a:t>3/31/2026</a:t>
+              <a:t>4/13/2026</a:t>
             </a:fld>
             <a:endParaRPr lang="en-US"/>
           </a:p>
@@ -1785,7 +1785,7 @@
           <a:p>
             <a:fld id="{02AC24A9-CCB6-4F8D-B8DB-C2F3692CFA5A}" type="datetimeFigureOut">
               <a:rPr lang="en-US" smtClean="0"/>
-              <a:t>3/31/2026</a:t>
+              <a:t>4/13/2026</a:t>
             </a:fld>
             <a:endParaRPr lang="en-US"/>
           </a:p>
@@ -2317,7 +2317,7 @@
           <a:p>
             <a:fld id="{02AC24A9-CCB6-4F8D-B8DB-C2F3692CFA5A}" type="datetimeFigureOut">
               <a:rPr lang="en-US" smtClean="0"/>
-              <a:t>3/31/2026</a:t>
+              <a:t>4/13/2026</a:t>
             </a:fld>
             <a:endParaRPr lang="en-US"/>
           </a:p>
@@ -3016,7 +3016,7 @@
           <a:p>
             <a:fld id="{02AC24A9-CCB6-4F8D-B8DB-C2F3692CFA5A}" type="datetimeFigureOut">
               <a:rPr lang="en-US" smtClean="0"/>
-              <a:t>3/31/2026</a:t>
+              <a:t>4/13/2026</a:t>
             </a:fld>
             <a:endParaRPr lang="en-US"/>
           </a:p>
@@ -3345,7 +3345,7 @@
           <a:p>
             <a:fld id="{02AC24A9-CCB6-4F8D-B8DB-C2F3692CFA5A}" type="datetimeFigureOut">
               <a:rPr lang="en-US" smtClean="0"/>
-              <a:t>3/31/2026</a:t>
+              <a:t>4/13/2026</a:t>
             </a:fld>
             <a:endParaRPr lang="en-US"/>
           </a:p>
@@ -3458,7 +3458,7 @@
           <a:p>
             <a:fld id="{02AC24A9-CCB6-4F8D-B8DB-C2F3692CFA5A}" type="datetimeFigureOut">
               <a:rPr lang="en-US" smtClean="0"/>
-              <a:t>3/31/2026</a:t>
+              <a:t>4/13/2026</a:t>
             </a:fld>
             <a:endParaRPr lang="en-US"/>
           </a:p>
@@ -3953,7 +3953,7 @@
           <a:p>
             <a:fld id="{02AC24A9-CCB6-4F8D-B8DB-C2F3692CFA5A}" type="datetimeFigureOut">
               <a:rPr lang="en-US" smtClean="0"/>
-              <a:t>3/31/2026</a:t>
+              <a:t>4/13/2026</a:t>
             </a:fld>
             <a:endParaRPr lang="en-US" dirty="0"/>
           </a:p>
@@ -4430,7 +4430,7 @@
           <a:p>
             <a:fld id="{02AC24A9-CCB6-4F8D-B8DB-C2F3692CFA5A}" type="datetimeFigureOut">
               <a:rPr lang="en-US" smtClean="0"/>
-              <a:t>3/31/2026</a:t>
+              <a:t>4/13/2026</a:t>
             </a:fld>
             <a:endParaRPr lang="en-US"/>
           </a:p>
@@ -4673,7 +4673,7 @@
           <a:p>
             <a:fld id="{02AC24A9-CCB6-4F8D-B8DB-C2F3692CFA5A}" type="datetimeFigureOut">
               <a:rPr lang="en-US" smtClean="0"/>
-              <a:t>3/31/2026</a:t>
+              <a:t>4/13/2026</a:t>
             </a:fld>
             <a:endParaRPr lang="en-US"/>
           </a:p>
@@ -5719,7 +5719,7 @@
           <p:cNvPr id="2" name="Title 1">
             <a:extLst>
               <a:ext uri="{FF2B5EF4-FFF2-40B4-BE49-F238E27FC236}">
-                <a16:creationId xmlns:a16="http://schemas.microsoft.com/office/drawing/2014/main" id="{3EFEEB55-547C-FCDF-229A-090DB5461C0F}"/>
+                <a16:creationId xmlns:a16="http://schemas.microsoft.com/office/drawing/2014/main" id="{302F263B-A652-181B-673E-98A944A25D16}"/>
               </a:ext>
             </a:extLst>
           </p:cNvPr>
@@ -5736,14 +5736,30 @@
           <a:lstStyle/>
           <a:p>
             <a:r>
-              <a:rPr lang="en-GB" dirty="0"/>
-              <a:t>Mi a </a:t>
-            </a:r>
-            <a:r>
-              <a:rPr lang="en-GB"/>
-              <a:t>NoSQL</a:t>
-            </a:r>
-            <a:endParaRPr lang="en-GB" dirty="0"/>
+              <a:rPr lang="en-GB" dirty="0">
+                <a:ea typeface="+mj-lt"/>
+                <a:cs typeface="+mj-lt"/>
+              </a:rPr>
+              <a:t>ACID </a:t>
+            </a:r>
+            <a:r>
+              <a:rPr lang="en-GB" dirty="0" err="1">
+                <a:ea typeface="+mj-lt"/>
+                <a:cs typeface="+mj-lt"/>
+              </a:rPr>
+              <a:t>tulajdonságok</a:t>
+            </a:r>
+            <a:r>
+              <a:rPr lang="en-GB" dirty="0">
+                <a:ea typeface="+mj-lt"/>
+                <a:cs typeface="+mj-lt"/>
+              </a:rPr>
+              <a:t> SQL-ben</a:t>
+            </a:r>
+            <a:endParaRPr lang="en-US" dirty="0">
+              <a:ea typeface="+mj-lt"/>
+              <a:cs typeface="+mj-lt"/>
+            </a:endParaRPr>
           </a:p>
         </p:txBody>
       </p:sp>
@@ -5752,7 +5768,7 @@
           <p:cNvPr id="3" name="Content Placeholder 2">
             <a:extLst>
               <a:ext uri="{FF2B5EF4-FFF2-40B4-BE49-F238E27FC236}">
-                <a16:creationId xmlns:a16="http://schemas.microsoft.com/office/drawing/2014/main" id="{5AEAC592-398C-C91C-176B-D3569E73E99B}"/>
+                <a16:creationId xmlns:a16="http://schemas.microsoft.com/office/drawing/2014/main" id="{2A84BCC9-4C85-A19D-F0D9-4B1E5D94461E}"/>
               </a:ext>
             </a:extLst>
           </p:cNvPr>
@@ -5763,13 +5779,321 @@
             <p:ph idx="1"/>
           </p:nvPr>
         </p:nvSpPr>
-        <p:spPr/>
+        <p:spPr>
+          <a:xfrm>
+            <a:off x="529414" y="1882101"/>
+            <a:ext cx="10168128" cy="3694176"/>
+          </a:xfrm>
+        </p:spPr>
         <p:txBody>
           <a:bodyPr vert="horz" lIns="91440" tIns="45720" rIns="91440" bIns="45720" rtlCol="0" anchor="t">
             <a:normAutofit/>
           </a:bodyPr>
           <a:lstStyle/>
           <a:p>
+            <a:pPr marL="0" indent="0">
+              <a:buNone/>
+            </a:pPr>
+            <a:r>
+              <a:rPr lang="en-GB" dirty="0"/>
+              <a:t>Az ACID a </a:t>
+            </a:r>
+            <a:r>
+              <a:rPr lang="en-GB" dirty="0" err="1"/>
+              <a:t>tranzakciók</a:t>
+            </a:r>
+            <a:r>
+              <a:rPr lang="en-GB" dirty="0"/>
+              <a:t> </a:t>
+            </a:r>
+            <a:r>
+              <a:rPr lang="en-GB" dirty="0" err="1"/>
+              <a:t>működésének</a:t>
+            </a:r>
+            <a:r>
+              <a:rPr lang="en-GB" dirty="0"/>
+              <a:t> </a:t>
+            </a:r>
+            <a:r>
+              <a:rPr lang="en-GB" dirty="0" err="1"/>
+              <a:t>szabályrendszere</a:t>
+            </a:r>
+            <a:endParaRPr lang="en-GB"/>
+          </a:p>
+          <a:p>
+            <a:endParaRPr lang="en-GB"/>
+          </a:p>
+          <a:p>
+            <a:r>
+              <a:rPr lang="en-GB" i="1" dirty="0"/>
+              <a:t>Atomicity</a:t>
+            </a:r>
+            <a:r>
+              <a:rPr lang="en-GB" dirty="0"/>
+              <a:t> = Minden </a:t>
+            </a:r>
+            <a:r>
+              <a:rPr lang="en-GB" dirty="0" err="1"/>
+              <a:t>vagy</a:t>
+            </a:r>
+            <a:r>
+              <a:rPr lang="en-GB" dirty="0"/>
+              <a:t> </a:t>
+            </a:r>
+            <a:r>
+              <a:rPr lang="en-GB" dirty="0" err="1"/>
+              <a:t>semmi</a:t>
+            </a:r>
+            <a:r>
+              <a:rPr lang="en-GB" dirty="0"/>
+              <a:t> (</a:t>
+            </a:r>
+            <a:r>
+              <a:rPr lang="en-GB" dirty="0" err="1"/>
+              <a:t>hiba</a:t>
+            </a:r>
+            <a:r>
+              <a:rPr lang="en-GB" dirty="0"/>
+              <a:t> </a:t>
+            </a:r>
+            <a:r>
+              <a:rPr lang="en-GB" dirty="0" err="1"/>
+              <a:t>esetén</a:t>
+            </a:r>
+            <a:r>
+              <a:rPr lang="en-GB" dirty="0"/>
+              <a:t> </a:t>
+            </a:r>
+            <a:r>
+              <a:rPr lang="en-GB" dirty="0" err="1"/>
+              <a:t>visszavonás</a:t>
+            </a:r>
+            <a:r>
+              <a:rPr lang="en-GB" dirty="0"/>
+              <a:t>)</a:t>
+            </a:r>
+          </a:p>
+          <a:p>
+            <a:r>
+              <a:rPr lang="en-GB" i="1" dirty="0"/>
+              <a:t>Consistency</a:t>
+            </a:r>
+            <a:r>
+              <a:rPr lang="en-GB" dirty="0"/>
+              <a:t> = Az </a:t>
+            </a:r>
+            <a:r>
+              <a:rPr lang="en-GB" dirty="0" err="1"/>
+              <a:t>adatbázis</a:t>
+            </a:r>
+            <a:r>
+              <a:rPr lang="en-GB" dirty="0"/>
+              <a:t> </a:t>
+            </a:r>
+            <a:r>
+              <a:rPr lang="en-GB" dirty="0" err="1"/>
+              <a:t>mindig</a:t>
+            </a:r>
+            <a:r>
+              <a:rPr lang="en-GB" dirty="0"/>
+              <a:t> </a:t>
+            </a:r>
+            <a:r>
+              <a:rPr lang="en-GB" dirty="0" err="1"/>
+              <a:t>helyes</a:t>
+            </a:r>
+            <a:r>
+              <a:rPr lang="en-GB" dirty="0"/>
+              <a:t> </a:t>
+            </a:r>
+            <a:r>
+              <a:rPr lang="en-GB" dirty="0" err="1"/>
+              <a:t>állapotban</a:t>
+            </a:r>
+            <a:r>
+              <a:rPr lang="en-GB" dirty="0"/>
+              <a:t> </a:t>
+            </a:r>
+            <a:r>
+              <a:rPr lang="en-GB" dirty="0" err="1"/>
+              <a:t>marad</a:t>
+            </a:r>
+            <a:endParaRPr lang="en-GB" dirty="0"/>
+          </a:p>
+          <a:p>
+            <a:r>
+              <a:rPr lang="en-GB" i="1" dirty="0"/>
+              <a:t>Isolation</a:t>
+            </a:r>
+            <a:r>
+              <a:rPr lang="en-GB" dirty="0"/>
+              <a:t> = </a:t>
+            </a:r>
+            <a:r>
+              <a:rPr lang="en-GB" dirty="0" err="1"/>
+              <a:t>Tranzakciók</a:t>
+            </a:r>
+            <a:r>
+              <a:rPr lang="en-GB" dirty="0"/>
+              <a:t> </a:t>
+            </a:r>
+            <a:r>
+              <a:rPr lang="en-GB" dirty="0" err="1"/>
+              <a:t>nem</a:t>
+            </a:r>
+            <a:r>
+              <a:rPr lang="en-GB" dirty="0"/>
+              <a:t> </a:t>
+            </a:r>
+            <a:r>
+              <a:rPr lang="en-GB" dirty="0" err="1"/>
+              <a:t>zavarják</a:t>
+            </a:r>
+            <a:r>
+              <a:rPr lang="en-GB" dirty="0"/>
+              <a:t> </a:t>
+            </a:r>
+            <a:r>
+              <a:rPr lang="en-GB" dirty="0" err="1"/>
+              <a:t>egymást</a:t>
+            </a:r>
+            <a:endParaRPr lang="en-GB" dirty="0"/>
+          </a:p>
+          <a:p>
+            <a:r>
+              <a:rPr lang="en-GB" i="1" dirty="0"/>
+              <a:t>Durability</a:t>
+            </a:r>
+            <a:r>
+              <a:rPr lang="en-GB" dirty="0"/>
+              <a:t> = </a:t>
+            </a:r>
+            <a:r>
+              <a:rPr lang="en-GB" dirty="0" err="1"/>
+              <a:t>Mentett</a:t>
+            </a:r>
+            <a:r>
+              <a:rPr lang="en-GB" dirty="0"/>
+              <a:t> </a:t>
+            </a:r>
+            <a:r>
+              <a:rPr lang="en-GB" dirty="0" err="1"/>
+              <a:t>adatok</a:t>
+            </a:r>
+            <a:r>
+              <a:rPr lang="en-GB" dirty="0"/>
+              <a:t> </a:t>
+            </a:r>
+            <a:r>
+              <a:rPr lang="en-GB" dirty="0" err="1"/>
+              <a:t>nem</a:t>
+            </a:r>
+            <a:r>
+              <a:rPr lang="en-GB" dirty="0"/>
+              <a:t> </a:t>
+            </a:r>
+            <a:r>
+              <a:rPr lang="en-GB" dirty="0" err="1"/>
+              <a:t>vesznek</a:t>
+            </a:r>
+            <a:r>
+              <a:rPr lang="en-GB" dirty="0"/>
+              <a:t> </a:t>
+            </a:r>
+            <a:r>
+              <a:rPr lang="en-GB" dirty="0" err="1"/>
+              <a:t>el</a:t>
+            </a:r>
+            <a:endParaRPr lang="en-GB" dirty="0"/>
+          </a:p>
+        </p:txBody>
+      </p:sp>
+    </p:spTree>
+    <p:extLst>
+      <p:ext uri="{BB962C8B-B14F-4D97-AF65-F5344CB8AC3E}">
+        <p14:creationId xmlns:p14="http://schemas.microsoft.com/office/powerpoint/2010/main" val="1702948451"/>
+      </p:ext>
+    </p:extLst>
+  </p:cSld>
+  <p:clrMapOvr>
+    <a:masterClrMapping/>
+  </p:clrMapOvr>
+</p:sld>
+</file>
+
+<file path=ppt/slides/slide4.xml><?xml version="1.0" encoding="utf-8"?>
+<p:sld xmlns:a="http://schemas.openxmlformats.org/drawingml/2006/main" xmlns:r="http://schemas.openxmlformats.org/officeDocument/2006/relationships" xmlns:p="http://schemas.openxmlformats.org/presentationml/2006/main">
+  <p:cSld>
+    <p:spTree>
+      <p:nvGrpSpPr>
+        <p:cNvPr id="1" name=""/>
+        <p:cNvGrpSpPr/>
+        <p:nvPr/>
+      </p:nvGrpSpPr>
+      <p:grpSpPr>
+        <a:xfrm>
+          <a:off x="0" y="0"/>
+          <a:ext cx="0" cy="0"/>
+          <a:chOff x="0" y="0"/>
+          <a:chExt cx="0" cy="0"/>
+        </a:xfrm>
+      </p:grpSpPr>
+      <p:sp>
+        <p:nvSpPr>
+          <p:cNvPr id="2" name="Title 1">
+            <a:extLst>
+              <a:ext uri="{FF2B5EF4-FFF2-40B4-BE49-F238E27FC236}">
+                <a16:creationId xmlns:a16="http://schemas.microsoft.com/office/drawing/2014/main" id="{3EFEEB55-547C-FCDF-229A-090DB5461C0F}"/>
+              </a:ext>
+            </a:extLst>
+          </p:cNvPr>
+          <p:cNvSpPr>
+            <a:spLocks noGrp="1"/>
+          </p:cNvSpPr>
+          <p:nvPr>
+            <p:ph type="title"/>
+          </p:nvPr>
+        </p:nvSpPr>
+        <p:spPr/>
+        <p:txBody>
+          <a:bodyPr/>
+          <a:lstStyle/>
+          <a:p>
+            <a:r>
+              <a:rPr lang="en-GB" dirty="0"/>
+              <a:t>Mi a </a:t>
+            </a:r>
+            <a:r>
+              <a:rPr lang="en-GB"/>
+              <a:t>NoSQL</a:t>
+            </a:r>
+            <a:endParaRPr lang="en-GB" dirty="0"/>
+          </a:p>
+        </p:txBody>
+      </p:sp>
+      <p:sp>
+        <p:nvSpPr>
+          <p:cNvPr id="3" name="Content Placeholder 2">
+            <a:extLst>
+              <a:ext uri="{FF2B5EF4-FFF2-40B4-BE49-F238E27FC236}">
+                <a16:creationId xmlns:a16="http://schemas.microsoft.com/office/drawing/2014/main" id="{5AEAC592-398C-C91C-176B-D3569E73E99B}"/>
+              </a:ext>
+            </a:extLst>
+          </p:cNvPr>
+          <p:cNvSpPr>
+            <a:spLocks noGrp="1"/>
+          </p:cNvSpPr>
+          <p:nvPr>
+            <p:ph idx="1"/>
+          </p:nvPr>
+        </p:nvSpPr>
+        <p:spPr/>
+        <p:txBody>
+          <a:bodyPr vert="horz" lIns="91440" tIns="45720" rIns="91440" bIns="45720" rtlCol="0" anchor="t">
+            <a:normAutofit/>
+          </a:bodyPr>
+          <a:lstStyle/>
+          <a:p>
             <a:r>
               <a:rPr lang="en-GB" dirty="0"/>
               <a:t>Nem </a:t>
@@ -5786,6 +6110,7 @@
               <a:rPr lang="en-GB" dirty="0" err="1"/>
               <a:t>adatbázis</a:t>
             </a:r>
+            <a:endParaRPr lang="en-GB" dirty="0"/>
           </a:p>
           <a:p>
             <a:r>
@@ -5798,11 +6123,7 @@
             </a:r>
             <a:r>
               <a:rPr lang="en-GB" dirty="0" err="1"/>
-              <a:t>adatmodel</a:t>
-            </a:r>
-            <a:r>
-              <a:rPr lang="en-GB" dirty="0"/>
-              <a:t>l</a:t>
+              <a:t>adatmodell</a:t>
             </a:r>
           </a:p>
           <a:p>
@@ -5822,6 +6143,7 @@
               <a:rPr lang="en-GB" dirty="0" err="1"/>
               <a:t>alapú</a:t>
             </a:r>
+            <a:endParaRPr lang="en-GB" dirty="0"/>
           </a:p>
           <a:p>
             <a:r>
@@ -5830,7 +6152,15 @@
             </a:r>
             <a:r>
               <a:rPr lang="en-GB" dirty="0"/>
-              <a:t>: MongoDB, Firebase</a:t>
+              <a:t>: </a:t>
+            </a:r>
+            <a:r>
+              <a:rPr lang="en-GB" i="1" dirty="0"/>
+              <a:t>MongoDB</a:t>
+            </a:r>
+            <a:r>
+              <a:rPr lang="en-GB" dirty="0"/>
+              <a:t>, Firebase</a:t>
             </a:r>
           </a:p>
         </p:txBody>
@@ -5848,7 +6178,7 @@
 </p:sld>
 </file>
 
-<file path=ppt/slides/slide4.xml><?xml version="1.0" encoding="utf-8"?>
+<file path=ppt/slides/slide5.xml><?xml version="1.0" encoding="utf-8"?>
 <p:sld xmlns:a="http://schemas.openxmlformats.org/drawingml/2006/main" xmlns:r="http://schemas.openxmlformats.org/officeDocument/2006/relationships" xmlns:p="http://schemas.openxmlformats.org/presentationml/2006/main">
   <p:cSld>
     <p:bg>
@@ -6609,7 +6939,7 @@
 </p:sld>
 </file>
 
-<file path=ppt/slides/slide5.xml><?xml version="1.0" encoding="utf-8"?>
+<file path=ppt/slides/slide6.xml><?xml version="1.0" encoding="utf-8"?>
 <p:sld xmlns:a="http://schemas.openxmlformats.org/drawingml/2006/main" xmlns:r="http://schemas.openxmlformats.org/officeDocument/2006/relationships" xmlns:p="http://schemas.openxmlformats.org/presentationml/2006/main">
   <p:cSld>
     <p:spTree>
@@ -6814,7 +7144,7 @@
 </p:sld>
 </file>
 
-<file path=ppt/slides/slide6.xml><?xml version="1.0" encoding="utf-8"?>
+<file path=ppt/slides/slide7.xml><?xml version="1.0" encoding="utf-8"?>
 <p:sld xmlns:a="http://schemas.openxmlformats.org/drawingml/2006/main" xmlns:r="http://schemas.openxmlformats.org/officeDocument/2006/relationships" xmlns:p="http://schemas.openxmlformats.org/presentationml/2006/main">
   <p:cSld>
     <p:bg>

</xml_diff>